<commit_message>
changes to time series plot description
</commit_message>
<xml_diff>
--- a/documentation/plot_info.pptx
+++ b/documentation/plot_info.pptx
@@ -121,7 +121,7 @@
 <file path=ppt/revisionInfo.xml><?xml version="1.0" encoding="utf-8"?>
 <p1510:revInfo xmlns:a="http://schemas.openxmlformats.org/drawingml/2006/main" xmlns:r="http://schemas.openxmlformats.org/officeDocument/2006/relationships" xmlns:p1510="http://schemas.microsoft.com/office/powerpoint/2015/10/main">
   <p1510:revLst>
-    <p1510:client id="{627AC242-72DC-43F1-B8D1-38D35556D062}" v="12" dt="2025-07-14T22:54:27.365"/>
+    <p1510:client id="{627AC242-72DC-43F1-B8D1-38D35556D062}" v="82" dt="2025-07-14T23:17:06.011"/>
   </p1510:revLst>
 </p1510:revInfo>
 </file>
@@ -521,7 +521,7 @@
           <a:lstStyle/>
           <a:p>
             <a:r>
-              <a:rPr lang="en-CA" dirty="0"/>
+              <a:rPr lang="en-CA"/>
               <a:t>Mention in the modal box that we can see from this plot that some models show an increase in PPT whereas others show a decrease</a:t>
             </a:r>
           </a:p>
@@ -607,7 +607,7 @@
           <a:bodyPr/>
           <a:lstStyle/>
           <a:p>
-            <a:endParaRPr lang="en-CA" dirty="0"/>
+            <a:endParaRPr lang="en-CA"/>
           </a:p>
         </p:txBody>
       </p:sp>
@@ -692,7 +692,7 @@
           <a:lstStyle/>
           <a:p>
             <a:r>
-              <a:rPr lang="en-CA" dirty="0"/>
+              <a:rPr lang="en-CA"/>
               <a:t>Interpreting the diagram: Temperature trends are displayed as the red line and precipitation trends are displayed as the blue line.</a:t>
             </a:r>
           </a:p>
@@ -4029,7 +4029,7 @@
           <a:p>
             <a:pPr algn="ctr"/>
             <a:r>
-              <a:rPr lang="en-CA" dirty="0"/>
+              <a:rPr lang="en-CA"/>
               <a:t>Time Series Plot for Mackenzie FLP Area</a:t>
             </a:r>
           </a:p>
@@ -4265,8 +4265,8 @@
         </p:nvSpPr>
         <p:spPr>
           <a:xfrm>
-            <a:off x="9177866" y="1767183"/>
-            <a:ext cx="2870200" cy="3600986"/>
+            <a:off x="9185335" y="1674850"/>
+            <a:ext cx="2870200" cy="3785652"/>
           </a:xfrm>
           <a:prstGeom prst="rect">
             <a:avLst/>
@@ -4280,29 +4280,29 @@
           <a:lstStyle/>
           <a:p>
             <a:r>
-              <a:rPr lang="en-CA" sz="1200" dirty="0"/>
+              <a:rPr lang="en-CA" sz="1200"/>
               <a:t>Years axis</a:t>
             </a:r>
           </a:p>
           <a:p>
-            <a:endParaRPr lang="en-CA" sz="1200" dirty="0"/>
-          </a:p>
-          <a:p>
-            <a:r>
-              <a:rPr lang="en-CA" sz="1200" dirty="0"/>
+            <a:endParaRPr lang="en-CA" sz="1200"/>
+          </a:p>
+          <a:p>
+            <a:r>
+              <a:rPr lang="en-CA" sz="1200"/>
               <a:t>Variable of interest axis</a:t>
             </a:r>
           </a:p>
           <a:p>
-            <a:endParaRPr lang="en-CA" sz="1200" dirty="0"/>
-          </a:p>
-          <a:p>
-            <a:r>
-              <a:rPr lang="en-CA" sz="1200" dirty="0"/>
+            <a:endParaRPr lang="en-CA" sz="1200"/>
+          </a:p>
+          <a:p>
+            <a:r>
+              <a:rPr lang="en-CA" sz="1200"/>
               <a:t>Simulated historic climate data using the recommended 8-GCM ensemble, from 1901-2014 (</a:t>
             </a:r>
             <a:r>
-              <a:rPr lang="en-CA" sz="1200" b="1" dirty="0">
+              <a:rPr lang="en-CA" sz="1200" b="1">
                 <a:solidFill>
                   <a:schemeClr val="bg2">
                     <a:lumMod val="50000"/>
@@ -4312,28 +4312,28 @@
               <a:t>gray </a:t>
             </a:r>
             <a:r>
-              <a:rPr lang="en-CA" sz="1200" dirty="0"/>
+              <a:rPr lang="en-CA" sz="1200"/>
               <a:t>shading)</a:t>
             </a:r>
           </a:p>
           <a:p>
-            <a:endParaRPr lang="en-CA" sz="1200" dirty="0"/>
-          </a:p>
-          <a:p>
-            <a:r>
-              <a:rPr lang="en-CA" sz="1200" dirty="0"/>
+            <a:endParaRPr lang="en-CA" sz="1200"/>
+          </a:p>
+          <a:p>
+            <a:r>
+              <a:rPr lang="en-CA" sz="1200"/>
               <a:t>Observed historic climate data by dataset (</a:t>
             </a:r>
             <a:r>
-              <a:rPr lang="en-CA" sz="1200" b="1" dirty="0"/>
+              <a:rPr lang="en-CA" sz="1200" b="1"/>
               <a:t>black</a:t>
             </a:r>
             <a:r>
-              <a:rPr lang="en-CA" sz="1200" dirty="0"/>
+              <a:rPr lang="en-CA" sz="1200"/>
               <a:t>, </a:t>
             </a:r>
             <a:r>
-              <a:rPr lang="en-CA" sz="1200" b="1" dirty="0">
+              <a:rPr lang="en-CA" sz="1200" b="1">
                 <a:solidFill>
                   <a:srgbClr val="F50C0A"/>
                 </a:solidFill>
@@ -4341,11 +4341,11 @@
               <a:t>red </a:t>
             </a:r>
             <a:r>
-              <a:rPr lang="en-CA" sz="1200" dirty="0"/>
+              <a:rPr lang="en-CA" sz="1200"/>
               <a:t>and </a:t>
             </a:r>
             <a:r>
-              <a:rPr lang="en-CA" sz="1200" b="1" dirty="0">
+              <a:rPr lang="en-CA" sz="1200" b="1">
                 <a:solidFill>
                   <a:srgbClr val="0000FF"/>
                 </a:solidFill>
@@ -4353,20 +4353,20 @@
               <a:t>blue </a:t>
             </a:r>
             <a:r>
-              <a:rPr lang="en-CA" sz="1200" dirty="0"/>
+              <a:rPr lang="en-CA" sz="1200"/>
               <a:t>lines), from 1901-2023</a:t>
             </a:r>
           </a:p>
           <a:p>
-            <a:endParaRPr lang="en-CA" sz="1200" dirty="0"/>
-          </a:p>
-          <a:p>
-            <a:r>
-              <a:rPr lang="en-CA" sz="1200" dirty="0"/>
-              <a:t>Simulated climate data, by range of each SSP (</a:t>
-            </a:r>
-            <a:r>
-              <a:rPr lang="en-CA" sz="1200" b="1" dirty="0">
+            <a:endParaRPr lang="en-CA" sz="1200"/>
+          </a:p>
+          <a:p>
+            <a:r>
+              <a:rPr lang="en-CA" sz="1200"/>
+              <a:t>Simulated climate data showing projected change in variable of interest, by range of each SSP (</a:t>
+            </a:r>
+            <a:r>
+              <a:rPr lang="en-CA" sz="1200" b="1">
                 <a:solidFill>
                   <a:srgbClr val="5681AD"/>
                 </a:solidFill>
@@ -4374,11 +4374,11 @@
               <a:t>blue</a:t>
             </a:r>
             <a:r>
-              <a:rPr lang="en-CA" sz="1200" dirty="0"/>
+              <a:rPr lang="en-CA" sz="1200"/>
               <a:t>, </a:t>
             </a:r>
             <a:r>
-              <a:rPr lang="en-CA" sz="1200" b="1" dirty="0">
+              <a:rPr lang="en-CA" sz="1200" b="1">
                 <a:solidFill>
                   <a:srgbClr val="6FAF8B"/>
                 </a:solidFill>
@@ -4386,11 +4386,11 @@
               <a:t>green</a:t>
             </a:r>
             <a:r>
-              <a:rPr lang="en-CA" sz="1200" dirty="0"/>
+              <a:rPr lang="en-CA" sz="1200"/>
               <a:t>, and </a:t>
             </a:r>
             <a:r>
-              <a:rPr lang="en-CA" sz="1200" b="1" dirty="0">
+              <a:rPr lang="en-CA" sz="1200" b="1">
                 <a:solidFill>
                   <a:srgbClr val="DC954F"/>
                 </a:solidFill>
@@ -4398,20 +4398,20 @@
               <a:t>orange </a:t>
             </a:r>
             <a:r>
-              <a:rPr lang="en-CA" sz="1200" dirty="0"/>
+              <a:rPr lang="en-CA" sz="1200"/>
               <a:t>shading), from 2015-2100</a:t>
             </a:r>
           </a:p>
           <a:p>
-            <a:endParaRPr lang="en-CA" sz="1200" dirty="0"/>
-          </a:p>
-          <a:p>
-            <a:r>
-              <a:rPr lang="en-CA" sz="1200" dirty="0"/>
-              <a:t>Projected change in variable of interest by SSP (</a:t>
-            </a:r>
-            <a:r>
-              <a:rPr lang="en-CA" sz="1200" b="1" dirty="0">
+            <a:endParaRPr lang="en-CA" sz="1200"/>
+          </a:p>
+          <a:p>
+            <a:r>
+              <a:rPr lang="en-CA" sz="1200"/>
+              <a:t>Mean projected change in variable of interest by SSP (</a:t>
+            </a:r>
+            <a:r>
+              <a:rPr lang="en-CA" sz="1200" b="1">
                 <a:solidFill>
                   <a:srgbClr val="5681AD"/>
                 </a:solidFill>
@@ -4419,11 +4419,11 @@
               <a:t>blue</a:t>
             </a:r>
             <a:r>
-              <a:rPr lang="en-CA" sz="1200" dirty="0"/>
+              <a:rPr lang="en-CA" sz="1200"/>
               <a:t>, </a:t>
             </a:r>
             <a:r>
-              <a:rPr lang="en-CA" sz="1200" b="1" dirty="0">
+              <a:rPr lang="en-CA" sz="1200" b="1">
                 <a:solidFill>
                   <a:srgbClr val="6FAF8B"/>
                 </a:solidFill>
@@ -4431,11 +4431,11 @@
               <a:t>green</a:t>
             </a:r>
             <a:r>
-              <a:rPr lang="en-CA" sz="1200" dirty="0"/>
+              <a:rPr lang="en-CA" sz="1200"/>
               <a:t>, and </a:t>
             </a:r>
             <a:r>
-              <a:rPr lang="en-CA" sz="1200" b="1" dirty="0">
+              <a:rPr lang="en-CA" sz="1200" b="1">
                 <a:solidFill>
                   <a:srgbClr val="DC954F"/>
                 </a:solidFill>
@@ -4443,7 +4443,7 @@
               <a:t>orange </a:t>
             </a:r>
             <a:r>
-              <a:rPr lang="en-CA" sz="1200" dirty="0"/>
+              <a:rPr lang="en-CA" sz="1200"/>
               <a:t>lines), from 2015-2100</a:t>
             </a:r>
           </a:p>
@@ -4477,7 +4477,7 @@
         </p:blipFill>
         <p:spPr>
           <a:xfrm>
-            <a:off x="8779932" y="1717705"/>
+            <a:off x="8779930" y="1622898"/>
             <a:ext cx="397933" cy="397933"/>
           </a:xfrm>
           <a:prstGeom prst="rect">
@@ -4513,7 +4513,7 @@
         </p:blipFill>
         <p:spPr>
           <a:xfrm>
-            <a:off x="8779931" y="2105053"/>
+            <a:off x="8787402" y="1998423"/>
             <a:ext cx="397933" cy="397933"/>
           </a:xfrm>
           <a:prstGeom prst="rect">
@@ -4549,7 +4549,7 @@
         </p:blipFill>
         <p:spPr>
           <a:xfrm>
-            <a:off x="8779930" y="2502986"/>
+            <a:off x="8787402" y="2394913"/>
             <a:ext cx="397933" cy="397933"/>
           </a:xfrm>
           <a:prstGeom prst="rect">
@@ -4585,7 +4585,7 @@
         </p:blipFill>
         <p:spPr>
           <a:xfrm>
-            <a:off x="8779930" y="3234932"/>
+            <a:off x="8787402" y="3130550"/>
             <a:ext cx="397933" cy="397933"/>
           </a:xfrm>
           <a:prstGeom prst="rect">
@@ -4621,7 +4621,7 @@
         </p:blipFill>
         <p:spPr>
           <a:xfrm>
-            <a:off x="8779930" y="3966878"/>
+            <a:off x="8787402" y="3866188"/>
             <a:ext cx="397933" cy="397933"/>
           </a:xfrm>
           <a:prstGeom prst="rect">
@@ -4657,7 +4657,7 @@
         </p:blipFill>
         <p:spPr>
           <a:xfrm>
-            <a:off x="8787402" y="4667523"/>
+            <a:off x="8787402" y="4785217"/>
             <a:ext cx="397933" cy="397933"/>
           </a:xfrm>
           <a:prstGeom prst="rect">
@@ -4725,7 +4725,7 @@
           <a:p>
             <a:pPr algn="ctr"/>
             <a:r>
-              <a:rPr lang="en-CA" dirty="0"/>
+              <a:rPr lang="en-CA"/>
               <a:t>Bivariate Plot for 100 Mile House FLP Area; 2041-2060</a:t>
             </a:r>
           </a:p>
@@ -4898,25 +4898,25 @@
           <a:lstStyle/>
           <a:p>
             <a:r>
-              <a:rPr lang="en-CA" sz="1200" dirty="0"/>
+              <a:rPr lang="en-CA" sz="1200"/>
               <a:t>Trajectory line for a specific GCM, the coloured circles along the line shows the ensemble mean for that GCM in 20-year increments</a:t>
             </a:r>
           </a:p>
           <a:p>
-            <a:endParaRPr lang="en-CA" sz="1200" dirty="0"/>
-          </a:p>
-          <a:p>
-            <a:r>
-              <a:rPr lang="en-CA" sz="1200" dirty="0"/>
+            <a:endParaRPr lang="en-CA" sz="1200"/>
+          </a:p>
+          <a:p>
+            <a:r>
+              <a:rPr lang="en-CA" sz="1200"/>
               <a:t>Smaller circles around the trajectory are the individual model runs for a specific (will be the same colour as the trajectory line)</a:t>
             </a:r>
           </a:p>
           <a:p>
-            <a:endParaRPr lang="en-CA" sz="1200" dirty="0"/>
-          </a:p>
-          <a:p>
-            <a:r>
-              <a:rPr lang="en-CA" sz="1200" dirty="0"/>
+            <a:endParaRPr lang="en-CA" sz="1200"/>
+          </a:p>
+          <a:p>
+            <a:r>
+              <a:rPr lang="en-CA" sz="1200"/>
               <a:t>Large circle with model name on the trajectory line shows the ensemble mean for that specific GCM in the period plotted (here, it is the ensemble mean for 2041-2060)</a:t>
             </a:r>
           </a:p>
@@ -5120,7 +5120,7 @@
           <a:p>
             <a:pPr algn="ctr"/>
             <a:r>
-              <a:rPr lang="en-CA" dirty="0"/>
+              <a:rPr lang="en-CA"/>
               <a:t>Bulkley-Morice FLP Area; 1961-1990</a:t>
             </a:r>
           </a:p>
@@ -5443,16 +5443,16 @@
           <a:lstStyle/>
           <a:p>
             <a:r>
-              <a:rPr lang="en-CA" sz="1200" dirty="0"/>
+              <a:rPr lang="en-CA" sz="1200"/>
               <a:t>Average annual temperature &amp; precipitation</a:t>
             </a:r>
           </a:p>
           <a:p>
-            <a:endParaRPr lang="en-CA" sz="1200" dirty="0"/>
-          </a:p>
-          <a:p>
-            <a:r>
-              <a:rPr lang="en-CA" sz="1200" dirty="0"/>
+            <a:endParaRPr lang="en-CA" sz="1200"/>
+          </a:p>
+          <a:p>
+            <a:r>
+              <a:rPr lang="en-CA" sz="1200"/>
               <a:t>Temperature axis</a:t>
             </a:r>
           </a:p>
@@ -5461,11 +5461,11 @@
               <a:buFontTx/>
               <a:buChar char="-"/>
             </a:pPr>
-            <a:endParaRPr lang="en-CA" sz="1200" dirty="0"/>
-          </a:p>
-          <a:p>
-            <a:r>
-              <a:rPr lang="en-CA" sz="1200" dirty="0"/>
+            <a:endParaRPr lang="en-CA" sz="1200"/>
+          </a:p>
+          <a:p>
+            <a:r>
+              <a:rPr lang="en-CA" sz="1200"/>
               <a:t>Precipitation axis</a:t>
             </a:r>
           </a:p>
@@ -5474,11 +5474,11 @@
               <a:buFontTx/>
               <a:buChar char="-"/>
             </a:pPr>
-            <a:endParaRPr lang="en-CA" sz="1200" dirty="0"/>
-          </a:p>
-          <a:p>
-            <a:r>
-              <a:rPr lang="en-CA" sz="1200" dirty="0"/>
+            <a:endParaRPr lang="en-CA" sz="1200"/>
+          </a:p>
+          <a:p>
+            <a:r>
+              <a:rPr lang="en-CA" sz="1200"/>
               <a:t>Months of the year</a:t>
             </a:r>
           </a:p>
@@ -5487,15 +5487,15 @@
               <a:buFontTx/>
               <a:buChar char="-"/>
             </a:pPr>
-            <a:endParaRPr lang="en-CA" sz="1200" dirty="0"/>
-          </a:p>
-          <a:p>
-            <a:r>
-              <a:rPr lang="en-CA" sz="1200" dirty="0"/>
+            <a:endParaRPr lang="en-CA" sz="1200"/>
+          </a:p>
+          <a:p>
+            <a:r>
+              <a:rPr lang="en-CA" sz="1200"/>
               <a:t>Months with frost likely (</a:t>
             </a:r>
             <a:r>
-              <a:rPr lang="en-CA" sz="1200" b="1" dirty="0">
+              <a:rPr lang="en-CA" sz="1200" b="1">
                 <a:solidFill>
                   <a:srgbClr val="4C4CFF"/>
                 </a:solidFill>
@@ -5503,7 +5503,7 @@
               <a:t>blue </a:t>
             </a:r>
             <a:r>
-              <a:rPr lang="en-CA" sz="1200" dirty="0"/>
+              <a:rPr lang="en-CA" sz="1200"/>
               <a:t>bars)</a:t>
             </a:r>
           </a:p>
@@ -5512,59 +5512,59 @@
               <a:buFontTx/>
               <a:buChar char="-"/>
             </a:pPr>
-            <a:endParaRPr lang="en-CA" sz="1200" dirty="0"/>
-          </a:p>
-          <a:p>
-            <a:r>
-              <a:rPr lang="en-CA" sz="1200" dirty="0"/>
+            <a:endParaRPr lang="en-CA" sz="1200"/>
+          </a:p>
+          <a:p>
+            <a:r>
+              <a:rPr lang="en-CA" sz="1200"/>
               <a:t>Average monthly </a:t>
             </a:r>
             <a:r>
-              <a:rPr lang="en-CA" sz="1200" b="1" dirty="0">
+              <a:rPr lang="en-CA" sz="1200" b="1">
                 <a:solidFill>
                   <a:srgbClr val="D90A27"/>
                 </a:solidFill>
               </a:rPr>
               <a:t>temperature curve</a:t>
             </a:r>
-            <a:endParaRPr lang="en-CA" sz="1200" dirty="0"/>
+            <a:endParaRPr lang="en-CA" sz="1200"/>
           </a:p>
           <a:p>
             <a:pPr marL="171450" indent="-171450">
               <a:buFontTx/>
               <a:buChar char="-"/>
             </a:pPr>
-            <a:endParaRPr lang="en-CA" sz="1200" dirty="0"/>
-          </a:p>
-          <a:p>
-            <a:r>
-              <a:rPr lang="en-CA" sz="1200" dirty="0"/>
+            <a:endParaRPr lang="en-CA" sz="1200"/>
+          </a:p>
+          <a:p>
+            <a:r>
+              <a:rPr lang="en-CA" sz="1200"/>
               <a:t>Average monthly </a:t>
             </a:r>
             <a:r>
-              <a:rPr lang="en-CA" sz="1200" b="1" dirty="0">
+              <a:rPr lang="en-CA" sz="1200" b="1">
                 <a:solidFill>
                   <a:srgbClr val="6B6BFF"/>
                 </a:solidFill>
               </a:rPr>
               <a:t>precipitation curve</a:t>
             </a:r>
-            <a:endParaRPr lang="en-CA" sz="1200" dirty="0"/>
+            <a:endParaRPr lang="en-CA" sz="1200"/>
           </a:p>
           <a:p>
             <a:pPr marL="171450" indent="-171450">
               <a:buFontTx/>
               <a:buChar char="-"/>
             </a:pPr>
-            <a:endParaRPr lang="en-CA" sz="1200" dirty="0"/>
-          </a:p>
-          <a:p>
-            <a:r>
-              <a:rPr lang="en-CA" sz="1200" dirty="0"/>
+            <a:endParaRPr lang="en-CA" sz="1200"/>
+          </a:p>
+          <a:p>
+            <a:r>
+              <a:rPr lang="en-CA" sz="1200"/>
               <a:t>Diurnal range (difference between the highest and lowest temperature recorded in a 24-hr period – </a:t>
             </a:r>
             <a:r>
-              <a:rPr lang="en-CA" sz="1200" b="1" dirty="0">
+              <a:rPr lang="en-CA" sz="1200" b="1">
                 <a:solidFill>
                   <a:srgbClr val="F50C0A"/>
                 </a:solidFill>
@@ -5572,7 +5572,7 @@
               <a:t>red</a:t>
             </a:r>
             <a:r>
-              <a:rPr lang="en-CA" sz="1200" b="1" dirty="0">
+              <a:rPr lang="en-CA" sz="1200" b="1">
                 <a:solidFill>
                   <a:srgbClr val="CC99CC"/>
                 </a:solidFill>
@@ -5580,7 +5580,7 @@
               <a:t> </a:t>
             </a:r>
             <a:r>
-              <a:rPr lang="en-CA" sz="1200" dirty="0"/>
+              <a:rPr lang="en-CA" sz="1200"/>
               <a:t>shading)</a:t>
             </a:r>
           </a:p>
@@ -5589,7 +5589,7 @@
               <a:buFontTx/>
               <a:buChar char="-"/>
             </a:pPr>
-            <a:endParaRPr lang="en-CA" sz="1200" dirty="0"/>
+            <a:endParaRPr lang="en-CA" sz="1200"/>
           </a:p>
         </p:txBody>
       </p:sp>
@@ -5971,7 +5971,7 @@
           <a:p>
             <a:pPr algn="ctr"/>
             <a:r>
-              <a:rPr lang="en-CA" dirty="0"/>
+              <a:rPr lang="en-CA"/>
               <a:t>Coast Range Ecoregion; 1961-1990</a:t>
             </a:r>
           </a:p>
@@ -6006,17 +6006,17 @@
           <a:lstStyle/>
           <a:p>
             <a:r>
-              <a:rPr lang="en-CA" b="1" u="sng" dirty="0"/>
+              <a:rPr lang="en-CA" b="1" u="sng"/>
               <a:t>Humid period:</a:t>
             </a:r>
           </a:p>
           <a:p>
             <a:r>
-              <a:rPr lang="en-CA" sz="1200" dirty="0"/>
+              <a:rPr lang="en-CA" sz="1200"/>
               <a:t>When the </a:t>
             </a:r>
             <a:r>
-              <a:rPr lang="en-CA" sz="1200" b="1" dirty="0">
+              <a:rPr lang="en-CA" sz="1200" b="1">
                 <a:solidFill>
                   <a:srgbClr val="6B6BFF"/>
                 </a:solidFill>
@@ -6024,11 +6024,11 @@
               <a:t>blue line </a:t>
             </a:r>
             <a:r>
-              <a:rPr lang="en-CA" sz="1200" dirty="0"/>
+              <a:rPr lang="en-CA" sz="1200"/>
               <a:t>is above the </a:t>
             </a:r>
             <a:r>
-              <a:rPr lang="en-CA" sz="1200" b="1" dirty="0">
+              <a:rPr lang="en-CA" sz="1200" b="1">
                 <a:solidFill>
                   <a:srgbClr val="D90A27"/>
                 </a:solidFill>
@@ -6036,14 +6036,14 @@
               <a:t>red line</a:t>
             </a:r>
             <a:r>
-              <a:rPr lang="en-CA" sz="1200" dirty="0"/>
+              <a:rPr lang="en-CA" sz="1200"/>
               <a:t>, conditions are </a:t>
             </a:r>
             <a:r>
-              <a:rPr lang="en-CA" sz="1200" b="1" dirty="0"/>
+              <a:rPr lang="en-CA" sz="1200" b="1"/>
               <a:t>humid</a:t>
             </a:r>
-            <a:endParaRPr lang="en-CA" sz="1200" dirty="0"/>
+            <a:endParaRPr lang="en-CA" sz="1200"/>
           </a:p>
         </p:txBody>
       </p:sp>
@@ -6148,17 +6148,17 @@
           <a:lstStyle/>
           <a:p>
             <a:r>
-              <a:rPr lang="en-CA" b="1" u="sng" dirty="0"/>
+              <a:rPr lang="en-CA" b="1" u="sng"/>
               <a:t>Wet period:</a:t>
             </a:r>
           </a:p>
           <a:p>
             <a:r>
-              <a:rPr lang="en-CA" sz="1200" dirty="0"/>
+              <a:rPr lang="en-CA" sz="1200"/>
               <a:t>When the </a:t>
             </a:r>
             <a:r>
-              <a:rPr lang="en-CA" sz="1200" b="1" dirty="0">
+              <a:rPr lang="en-CA" sz="1200" b="1">
                 <a:solidFill>
                   <a:srgbClr val="6B6BFF"/>
                 </a:solidFill>
@@ -6166,14 +6166,14 @@
               <a:t>blue line </a:t>
             </a:r>
             <a:r>
-              <a:rPr lang="en-CA" sz="1200" dirty="0"/>
+              <a:rPr lang="en-CA" sz="1200"/>
               <a:t>is above 100m, conditions are </a:t>
             </a:r>
             <a:r>
-              <a:rPr lang="en-CA" sz="1200" b="1" dirty="0"/>
+              <a:rPr lang="en-CA" sz="1200" b="1"/>
               <a:t>wet</a:t>
             </a:r>
-            <a:endParaRPr lang="en-CA" sz="1200" dirty="0"/>
+            <a:endParaRPr lang="en-CA" sz="1200"/>
           </a:p>
         </p:txBody>
       </p:sp>
@@ -6242,17 +6242,17 @@
           <a:lstStyle/>
           <a:p>
             <a:r>
-              <a:rPr lang="en-CA" b="1" u="sng" dirty="0"/>
+              <a:rPr lang="en-CA" b="1" u="sng"/>
               <a:t>Dry period:</a:t>
             </a:r>
           </a:p>
           <a:p>
             <a:r>
-              <a:rPr lang="en-CA" sz="1200" dirty="0"/>
+              <a:rPr lang="en-CA" sz="1200"/>
               <a:t>When the </a:t>
             </a:r>
             <a:r>
-              <a:rPr lang="en-CA" sz="1200" b="1" dirty="0">
+              <a:rPr lang="en-CA" sz="1200" b="1">
                 <a:solidFill>
                   <a:srgbClr val="D90A27"/>
                 </a:solidFill>
@@ -6260,11 +6260,11 @@
               <a:t>red line </a:t>
             </a:r>
             <a:r>
-              <a:rPr lang="en-CA" sz="1200" dirty="0"/>
+              <a:rPr lang="en-CA" sz="1200"/>
               <a:t>is above the </a:t>
             </a:r>
             <a:r>
-              <a:rPr lang="en-CA" sz="1200" b="1" dirty="0">
+              <a:rPr lang="en-CA" sz="1200" b="1">
                 <a:solidFill>
                   <a:srgbClr val="6B6BFF"/>
                 </a:solidFill>
@@ -6272,14 +6272,14 @@
               <a:t>blue line</a:t>
             </a:r>
             <a:r>
-              <a:rPr lang="en-CA" sz="1200" dirty="0"/>
+              <a:rPr lang="en-CA" sz="1200"/>
               <a:t>, conditions are </a:t>
             </a:r>
             <a:r>
-              <a:rPr lang="en-CA" sz="1200" b="1" dirty="0"/>
+              <a:rPr lang="en-CA" sz="1200" b="1"/>
               <a:t>dry</a:t>
             </a:r>
-            <a:endParaRPr lang="en-CA" sz="1200" dirty="0"/>
+            <a:endParaRPr lang="en-CA" sz="1200"/>
           </a:p>
         </p:txBody>
       </p:sp>

</xml_diff>

<commit_message>
changes to plot docs
</commit_message>
<xml_diff>
--- a/documentation/plot_info.pptx
+++ b/documentation/plot_info.pptx
@@ -7304,7 +7304,7 @@
         </p:blipFill>
         <p:spPr>
           <a:xfrm>
-            <a:off x="1920876" y="484283"/>
+            <a:off x="574168" y="641773"/>
             <a:ext cx="8147050" cy="5889434"/>
           </a:xfrm>
           <a:prstGeom prst="rect">
@@ -7326,7 +7326,7 @@
         </p:nvSpPr>
         <p:spPr>
           <a:xfrm>
-            <a:off x="2438401" y="115124"/>
+            <a:off x="1091693" y="272441"/>
             <a:ext cx="7112000" cy="369332"/>
           </a:xfrm>
           <a:prstGeom prst="rect">
@@ -7362,7 +7362,7 @@
         </p:nvSpPr>
         <p:spPr>
           <a:xfrm>
-            <a:off x="186267" y="2294467"/>
+            <a:off x="9636587" y="4074507"/>
             <a:ext cx="1836208" cy="923330"/>
           </a:xfrm>
           <a:prstGeom prst="rect">
@@ -7432,7 +7432,7 @@
         </p:nvSpPr>
         <p:spPr>
           <a:xfrm>
-            <a:off x="10168469" y="1064654"/>
+            <a:off x="8811617" y="1192473"/>
             <a:ext cx="1649941" cy="923330"/>
           </a:xfrm>
           <a:prstGeom prst="rect">
@@ -7490,7 +7490,7 @@
         </p:nvSpPr>
         <p:spPr>
           <a:xfrm>
-            <a:off x="5918201" y="2852802"/>
+            <a:off x="4647693" y="2967335"/>
             <a:ext cx="1523999" cy="923330"/>
           </a:xfrm>
           <a:prstGeom prst="rect">
@@ -7548,48 +7548,6 @@
       </p:sp>
       <p:cxnSp>
         <p:nvCxnSpPr>
-          <p:cNvPr id="3" name="Straight Arrow Connector 2">
-            <a:extLst>
-              <a:ext uri="{FF2B5EF4-FFF2-40B4-BE49-F238E27FC236}">
-                <a16:creationId xmlns:a16="http://schemas.microsoft.com/office/drawing/2014/main" id="{76A3993D-EB61-D6D5-8A03-8A5C788C956E}"/>
-              </a:ext>
-            </a:extLst>
-          </p:cNvPr>
-          <p:cNvCxnSpPr/>
-          <p:nvPr/>
-        </p:nvCxnSpPr>
-        <p:spPr>
-          <a:xfrm>
-            <a:off x="1920876" y="2494722"/>
-            <a:ext cx="3187837" cy="0"/>
-          </a:xfrm>
-          <a:prstGeom prst="straightConnector1">
-            <a:avLst/>
-          </a:prstGeom>
-          <a:ln w="44450">
-            <a:solidFill>
-              <a:schemeClr val="tx1"/>
-            </a:solidFill>
-            <a:tailEnd type="triangle" w="lg" len="lg"/>
-          </a:ln>
-        </p:spPr>
-        <p:style>
-          <a:lnRef idx="2">
-            <a:schemeClr val="accent1"/>
-          </a:lnRef>
-          <a:fillRef idx="0">
-            <a:schemeClr val="accent1"/>
-          </a:fillRef>
-          <a:effectRef idx="1">
-            <a:schemeClr val="accent1"/>
-          </a:effectRef>
-          <a:fontRef idx="minor">
-            <a:schemeClr val="tx1"/>
-          </a:fontRef>
-        </p:style>
-      </p:cxnSp>
-      <p:cxnSp>
-        <p:nvCxnSpPr>
           <p:cNvPr id="4" name="Straight Arrow Connector 3">
             <a:extLst>
               <a:ext uri="{FF2B5EF4-FFF2-40B4-BE49-F238E27FC236}">
@@ -7604,7 +7562,7 @@
         </p:nvCxnSpPr>
         <p:spPr>
           <a:xfrm>
-            <a:off x="6579704" y="3776132"/>
+            <a:off x="5193356" y="3946687"/>
             <a:ext cx="0" cy="865442"/>
           </a:xfrm>
           <a:prstGeom prst="straightConnector1">
@@ -7648,8 +7606,52 @@
         </p:nvCxnSpPr>
         <p:spPr>
           <a:xfrm flipH="1">
-            <a:off x="9203635" y="1338470"/>
+            <a:off x="7846783" y="1456457"/>
             <a:ext cx="964834" cy="0"/>
+          </a:xfrm>
+          <a:prstGeom prst="straightConnector1">
+            <a:avLst/>
+          </a:prstGeom>
+          <a:ln w="44450">
+            <a:solidFill>
+              <a:schemeClr val="tx1"/>
+            </a:solidFill>
+            <a:tailEnd type="triangle" w="lg" len="lg"/>
+          </a:ln>
+        </p:spPr>
+        <p:style>
+          <a:lnRef idx="2">
+            <a:schemeClr val="accent1"/>
+          </a:lnRef>
+          <a:fillRef idx="0">
+            <a:schemeClr val="accent1"/>
+          </a:fillRef>
+          <a:effectRef idx="1">
+            <a:schemeClr val="accent1"/>
+          </a:effectRef>
+          <a:fontRef idx="minor">
+            <a:schemeClr val="tx1"/>
+          </a:fontRef>
+        </p:style>
+      </p:cxnSp>
+      <p:cxnSp>
+        <p:nvCxnSpPr>
+          <p:cNvPr id="2" name="Straight Arrow Connector 1">
+            <a:extLst>
+              <a:ext uri="{FF2B5EF4-FFF2-40B4-BE49-F238E27FC236}">
+                <a16:creationId xmlns:a16="http://schemas.microsoft.com/office/drawing/2014/main" id="{EC5CB9AB-AA26-A709-0CF1-74AD34840045}"/>
+              </a:ext>
+            </a:extLst>
+          </p:cNvPr>
+          <p:cNvCxnSpPr>
+            <a:cxnSpLocks/>
+          </p:cNvCxnSpPr>
+          <p:nvPr/>
+        </p:nvCxnSpPr>
+        <p:spPr>
+          <a:xfrm flipH="1">
+            <a:off x="7086739" y="4375774"/>
+            <a:ext cx="2549848" cy="0"/>
           </a:xfrm>
           <a:prstGeom prst="straightConnector1">
             <a:avLst/>

</xml_diff>